<commit_message>
Fence the bank-side boundary and drop the existing plaques from costs
A 40 m post-and-rail fence now runs the full length of the north
boundary behind the stage, where the bank drops steeply and the
neighbouring plot begins. The open rail style keeps the lake readable
above and between the rails, so the view the stage was turned toward
survives. Plan and schedule carry it; the note states that the fence on
the other three sides is assumed serviceable and excluded.

The club and library plaques are already on the building, so their line
leaves the schedule and they move into the existing-building entry -
still modelled, for orientation.

Schedule: 29 items, 3 075 060 RUB direct plus 5 per cent, 3 228 813 RUB
total, 271 187 RUB of headroom. Deck figures, chart and item list
rebuilt to match, and its renders re-shot with the new fence.

Co-Authored-By: Claude Opus 5 <noreply@anthropic.com>
Claude-Session: https://claude.ai/code/session_01BYykK3eroz4Z1NYhLotbmM
</commit_message>
<xml_diff>
--- a/polyanka-prezentaciya.pptx
+++ b/polyanka-prezentaciya.pptx
@@ -222,7 +222,7 @@
                   <c:v>713800</c:v>
                 </c:pt>
                 <c:pt idx="4">
-                  <c:v>528000</c:v>
+                  <c:v>575000</c:v>
                 </c:pt>
                 <c:pt idx="5">
                   <c:v>18000</c:v>
@@ -937,7 +937,7 @@
           <a:p>
             <a:r>
               <a:rPr lang="en-US" dirty="0"/>
-              <a:t>Ведомость не является сметой по ТЕР/ФЕР; для конкурсной документации нужен локальный сметный расчёт.</a:t>
+              <a:t>Ведомость не является сметой по ТЕР/ФЕР; для конкурсной документации нужен локальный сметный расчёт. Существующее ограждение по трём сторонам принято исправным и не включено.</a:t>
             </a:r>
             <a:endParaRPr lang="en-US" dirty="0"/>
           </a:p>
@@ -2575,7 +2575,7 @@
                 <a:ea typeface="Cambria" pitchFamily="34" charset="-122"/>
                 <a:cs typeface="Cambria" pitchFamily="34" charset="-120"/>
               </a:rPr>
-              <a:t>3 179 463 ₽</a:t>
+              <a:t>3 228 813 ₽</a:t>
             </a:r>
             <a:endParaRPr lang="en-US" sz="1700" dirty="0"/>
           </a:p>
@@ -3177,7 +3177,7 @@
                 <a:ea typeface="Cambria" pitchFamily="34" charset="-122"/>
                 <a:cs typeface="Cambria" pitchFamily="34" charset="-120"/>
               </a:rPr>
-              <a:t>3 179 463 ₽ при лимите 3,5 млн</a:t>
+              <a:t>3 228 813 ₽ при лимите 3,5 млн</a:t>
             </a:r>
             <a:endParaRPr lang="en-US" sz="3200" dirty="0"/>
           </a:p>
@@ -3271,7 +3271,7 @@
                 <a:ea typeface="Cambria" pitchFamily="34" charset="-122"/>
                 <a:cs typeface="Cambria" pitchFamily="34" charset="-120"/>
               </a:rPr>
-              <a:t>3 028 060 ₽</a:t>
+              <a:t>3 075 060 ₽</a:t>
             </a:r>
             <a:endParaRPr lang="en-US" sz="2100" dirty="0"/>
           </a:p>
@@ -3349,7 +3349,7 @@
                 <a:ea typeface="Cambria" pitchFamily="34" charset="-122"/>
                 <a:cs typeface="Cambria" pitchFamily="34" charset="-120"/>
               </a:rPr>
-              <a:t>151 403 ₽</a:t>
+              <a:t>153 753 ₽</a:t>
             </a:r>
             <a:endParaRPr lang="en-US" sz="2100" dirty="0"/>
           </a:p>
@@ -3427,7 +3427,7 @@
                 <a:ea typeface="Cambria" pitchFamily="34" charset="-122"/>
                 <a:cs typeface="Cambria" pitchFamily="34" charset="-120"/>
               </a:rPr>
-              <a:t>320 537 ₽</a:t>
+              <a:t>271 187 ₽</a:t>
             </a:r>
             <a:endParaRPr lang="en-US" sz="2100" dirty="0"/>
           </a:p>
@@ -3466,7 +3466,7 @@
                 <a:ea typeface="Calibri" pitchFamily="34" charset="-122"/>
                 <a:cs typeface="Calibri" pitchFamily="34" charset="-120"/>
               </a:rPr>
-              <a:t>запас до лимита, 9,2 %</a:t>
+              <a:t>запас до лимита, 7,7 %</a:t>
             </a:r>
             <a:endParaRPr lang="en-US" sz="1100" dirty="0"/>
           </a:p>
@@ -4270,7 +4270,7 @@
                 <a:ea typeface="Cambria" pitchFamily="34" charset="-122"/>
                 <a:cs typeface="Cambria" pitchFamily="34" charset="-120"/>
               </a:rPr>
-              <a:t>3 179 463 ₽</a:t>
+              <a:t>3 228 813 ₽</a:t>
             </a:r>
             <a:endParaRPr lang="en-US" sz="2800" dirty="0"/>
           </a:p>
@@ -5746,7 +5746,7 @@
         </p:nvSpPr>
         <p:spPr>
           <a:xfrm>
-            <a:off x="5806440" y="1783080"/>
+            <a:off x="5806440" y="1691640"/>
             <a:ext cx="329184" cy="329184"/>
           </a:xfrm>
           <a:prstGeom prst="ellipse">
@@ -5766,7 +5766,7 @@
         </p:nvSpPr>
         <p:spPr>
           <a:xfrm>
-            <a:off x="5806440" y="1783080"/>
+            <a:off x="5806440" y="1691640"/>
             <a:ext cx="329184" cy="329184"/>
           </a:xfrm>
           <a:prstGeom prst="rect">
@@ -5805,7 +5805,7 @@
         </p:nvSpPr>
         <p:spPr>
           <a:xfrm>
-            <a:off x="6309360" y="1737360"/>
+            <a:off x="6309360" y="1645920"/>
             <a:ext cx="5303520" cy="237744"/>
           </a:xfrm>
           <a:prstGeom prst="rect">
@@ -5844,7 +5844,7 @@
         </p:nvSpPr>
         <p:spPr>
           <a:xfrm>
-            <a:off x="6309360" y="1965960"/>
+            <a:off x="6309360" y="1874520"/>
             <a:ext cx="5303520" cy="219456"/>
           </a:xfrm>
           <a:prstGeom prst="rect">
@@ -5883,7 +5883,7 @@
         </p:nvSpPr>
         <p:spPr>
           <a:xfrm>
-            <a:off x="5806440" y="2295144"/>
+            <a:off x="5806440" y="2185416"/>
             <a:ext cx="329184" cy="329184"/>
           </a:xfrm>
           <a:prstGeom prst="ellipse">
@@ -5903,7 +5903,7 @@
         </p:nvSpPr>
         <p:spPr>
           <a:xfrm>
-            <a:off x="5806440" y="2295144"/>
+            <a:off x="5806440" y="2185416"/>
             <a:ext cx="329184" cy="329184"/>
           </a:xfrm>
           <a:prstGeom prst="rect">
@@ -5942,7 +5942,7 @@
         </p:nvSpPr>
         <p:spPr>
           <a:xfrm>
-            <a:off x="6309360" y="2249424"/>
+            <a:off x="6309360" y="2139696"/>
             <a:ext cx="5303520" cy="237744"/>
           </a:xfrm>
           <a:prstGeom prst="rect">
@@ -5981,7 +5981,7 @@
         </p:nvSpPr>
         <p:spPr>
           <a:xfrm>
-            <a:off x="6309360" y="2478024"/>
+            <a:off x="6309360" y="2368296"/>
             <a:ext cx="5303520" cy="219456"/>
           </a:xfrm>
           <a:prstGeom prst="rect">
@@ -6020,7 +6020,7 @@
         </p:nvSpPr>
         <p:spPr>
           <a:xfrm>
-            <a:off x="5806440" y="2807208"/>
+            <a:off x="5806440" y="2679192"/>
             <a:ext cx="329184" cy="329184"/>
           </a:xfrm>
           <a:prstGeom prst="ellipse">
@@ -6040,7 +6040,7 @@
         </p:nvSpPr>
         <p:spPr>
           <a:xfrm>
-            <a:off x="5806440" y="2807208"/>
+            <a:off x="5806440" y="2679192"/>
             <a:ext cx="329184" cy="329184"/>
           </a:xfrm>
           <a:prstGeom prst="rect">
@@ -6079,7 +6079,7 @@
         </p:nvSpPr>
         <p:spPr>
           <a:xfrm>
-            <a:off x="6309360" y="2761488"/>
+            <a:off x="6309360" y="2633472"/>
             <a:ext cx="5303520" cy="237744"/>
           </a:xfrm>
           <a:prstGeom prst="rect">
@@ -6118,7 +6118,7 @@
         </p:nvSpPr>
         <p:spPr>
           <a:xfrm>
-            <a:off x="6309360" y="2990088"/>
+            <a:off x="6309360" y="2862072"/>
             <a:ext cx="5303520" cy="219456"/>
           </a:xfrm>
           <a:prstGeom prst="rect">
@@ -6157,7 +6157,7 @@
         </p:nvSpPr>
         <p:spPr>
           <a:xfrm>
-            <a:off x="5806440" y="3319272"/>
+            <a:off x="5806440" y="3172968"/>
             <a:ext cx="329184" cy="329184"/>
           </a:xfrm>
           <a:prstGeom prst="ellipse">
@@ -6177,7 +6177,7 @@
         </p:nvSpPr>
         <p:spPr>
           <a:xfrm>
-            <a:off x="5806440" y="3319272"/>
+            <a:off x="5806440" y="3172968"/>
             <a:ext cx="329184" cy="329184"/>
           </a:xfrm>
           <a:prstGeom prst="rect">
@@ -6216,7 +6216,7 @@
         </p:nvSpPr>
         <p:spPr>
           <a:xfrm>
-            <a:off x="6309360" y="3273552"/>
+            <a:off x="6309360" y="3127248"/>
             <a:ext cx="5303520" cy="237744"/>
           </a:xfrm>
           <a:prstGeom prst="rect">
@@ -6255,7 +6255,7 @@
         </p:nvSpPr>
         <p:spPr>
           <a:xfrm>
-            <a:off x="6309360" y="3502152"/>
+            <a:off x="6309360" y="3355848"/>
             <a:ext cx="5303520" cy="219456"/>
           </a:xfrm>
           <a:prstGeom prst="rect">
@@ -6294,7 +6294,7 @@
         </p:nvSpPr>
         <p:spPr>
           <a:xfrm>
-            <a:off x="5806440" y="3831336"/>
+            <a:off x="5806440" y="3666744"/>
             <a:ext cx="329184" cy="329184"/>
           </a:xfrm>
           <a:prstGeom prst="ellipse">
@@ -6314,7 +6314,7 @@
         </p:nvSpPr>
         <p:spPr>
           <a:xfrm>
-            <a:off x="5806440" y="3831336"/>
+            <a:off x="5806440" y="3666744"/>
             <a:ext cx="329184" cy="329184"/>
           </a:xfrm>
           <a:prstGeom prst="rect">
@@ -6353,7 +6353,7 @@
         </p:nvSpPr>
         <p:spPr>
           <a:xfrm>
-            <a:off x="6309360" y="3785616"/>
+            <a:off x="6309360" y="3621024"/>
             <a:ext cx="5303520" cy="237744"/>
           </a:xfrm>
           <a:prstGeom prst="rect">
@@ -6392,7 +6392,7 @@
         </p:nvSpPr>
         <p:spPr>
           <a:xfrm>
-            <a:off x="6309360" y="4014216"/>
+            <a:off x="6309360" y="3849624"/>
             <a:ext cx="5303520" cy="219456"/>
           </a:xfrm>
           <a:prstGeom prst="rect">
@@ -6431,7 +6431,7 @@
         </p:nvSpPr>
         <p:spPr>
           <a:xfrm>
-            <a:off x="5806440" y="4343400"/>
+            <a:off x="5806440" y="4160520"/>
             <a:ext cx="329184" cy="329184"/>
           </a:xfrm>
           <a:prstGeom prst="ellipse">
@@ -6451,7 +6451,7 @@
         </p:nvSpPr>
         <p:spPr>
           <a:xfrm>
-            <a:off x="5806440" y="4343400"/>
+            <a:off x="5806440" y="4160520"/>
             <a:ext cx="329184" cy="329184"/>
           </a:xfrm>
           <a:prstGeom prst="rect">
@@ -6490,7 +6490,7 @@
         </p:nvSpPr>
         <p:spPr>
           <a:xfrm>
-            <a:off x="6309360" y="4297680"/>
+            <a:off x="6309360" y="4114800"/>
             <a:ext cx="5303520" cy="237744"/>
           </a:xfrm>
           <a:prstGeom prst="rect">
@@ -6529,7 +6529,7 @@
         </p:nvSpPr>
         <p:spPr>
           <a:xfrm>
-            <a:off x="6309360" y="4526280"/>
+            <a:off x="6309360" y="4343400"/>
             <a:ext cx="5303520" cy="219456"/>
           </a:xfrm>
           <a:prstGeom prst="rect">
@@ -6568,7 +6568,7 @@
         </p:nvSpPr>
         <p:spPr>
           <a:xfrm>
-            <a:off x="5806440" y="4855464"/>
+            <a:off x="5806440" y="4654296"/>
             <a:ext cx="329184" cy="329184"/>
           </a:xfrm>
           <a:prstGeom prst="ellipse">
@@ -6588,7 +6588,7 @@
         </p:nvSpPr>
         <p:spPr>
           <a:xfrm>
-            <a:off x="5806440" y="4855464"/>
+            <a:off x="5806440" y="4654296"/>
             <a:ext cx="329184" cy="329184"/>
           </a:xfrm>
           <a:prstGeom prst="rect">
@@ -6627,7 +6627,7 @@
         </p:nvSpPr>
         <p:spPr>
           <a:xfrm>
-            <a:off x="6309360" y="4809744"/>
+            <a:off x="6309360" y="4608576"/>
             <a:ext cx="5303520" cy="237744"/>
           </a:xfrm>
           <a:prstGeom prst="rect">
@@ -6666,7 +6666,7 @@
         </p:nvSpPr>
         <p:spPr>
           <a:xfrm>
-            <a:off x="6309360" y="5038344"/>
+            <a:off x="6309360" y="4837176"/>
             <a:ext cx="5303520" cy="219456"/>
           </a:xfrm>
           <a:prstGeom prst="rect">
@@ -6705,7 +6705,7 @@
         </p:nvSpPr>
         <p:spPr>
           <a:xfrm>
-            <a:off x="5806440" y="5367528"/>
+            <a:off x="5806440" y="5148072"/>
             <a:ext cx="329184" cy="329184"/>
           </a:xfrm>
           <a:prstGeom prst="ellipse">
@@ -6725,7 +6725,7 @@
         </p:nvSpPr>
         <p:spPr>
           <a:xfrm>
-            <a:off x="5806440" y="5367528"/>
+            <a:off x="5806440" y="5148072"/>
             <a:ext cx="329184" cy="329184"/>
           </a:xfrm>
           <a:prstGeom prst="rect">
@@ -6764,7 +6764,7 @@
         </p:nvSpPr>
         <p:spPr>
           <a:xfrm>
-            <a:off x="6309360" y="5321808"/>
+            <a:off x="6309360" y="5102352"/>
             <a:ext cx="5303520" cy="237744"/>
           </a:xfrm>
           <a:prstGeom prst="rect">
@@ -6789,7 +6789,7 @@
                 <a:ea typeface="Calibri" pitchFamily="34" charset="-122"/>
                 <a:cs typeface="Calibri" pitchFamily="34" charset="-120"/>
               </a:rPr>
-              <a:t>Таблички на фасаде</a:t>
+              <a:t>Парковка</a:t>
             </a:r>
             <a:endParaRPr lang="en-US" sz="1250" dirty="0"/>
           </a:p>
@@ -6803,7 +6803,7 @@
         </p:nvSpPr>
         <p:spPr>
           <a:xfrm>
-            <a:off x="6309360" y="5550408"/>
+            <a:off x="6309360" y="5330952"/>
             <a:ext cx="5303520" cy="219456"/>
           </a:xfrm>
           <a:prstGeom prst="rect">
@@ -6828,7 +6828,7 @@
                 <a:ea typeface="Calibri" pitchFamily="34" charset="-122"/>
                 <a:cs typeface="Calibri" pitchFamily="34" charset="-120"/>
               </a:rPr>
-              <a:t>клуб и библиотека, под золото</a:t>
+              <a:t>6 мест на крошке, вне ограждения</a:t>
             </a:r>
             <a:endParaRPr lang="en-US" sz="1050" dirty="0"/>
           </a:p>
@@ -6842,7 +6842,7 @@
         </p:nvSpPr>
         <p:spPr>
           <a:xfrm>
-            <a:off x="5806440" y="5879592"/>
+            <a:off x="5806440" y="5641848"/>
             <a:ext cx="329184" cy="329184"/>
           </a:xfrm>
           <a:prstGeom prst="ellipse">
@@ -6862,7 +6862,7 @@
         </p:nvSpPr>
         <p:spPr>
           <a:xfrm>
-            <a:off x="5806440" y="5879592"/>
+            <a:off x="5806440" y="5641848"/>
             <a:ext cx="329184" cy="329184"/>
           </a:xfrm>
           <a:prstGeom prst="rect">
@@ -6901,7 +6901,7 @@
         </p:nvSpPr>
         <p:spPr>
           <a:xfrm>
-            <a:off x="6309360" y="5833872"/>
+            <a:off x="6309360" y="5596128"/>
             <a:ext cx="5303520" cy="237744"/>
           </a:xfrm>
           <a:prstGeom prst="rect">
@@ -6926,7 +6926,7 @@
                 <a:ea typeface="Calibri" pitchFamily="34" charset="-122"/>
                 <a:cs typeface="Calibri" pitchFamily="34" charset="-120"/>
               </a:rPr>
-              <a:t>Парковка</a:t>
+              <a:t>Ограждение по бровке берега</a:t>
             </a:r>
             <a:endParaRPr lang="en-US" sz="1250" dirty="0"/>
           </a:p>
@@ -6940,7 +6940,7 @@
         </p:nvSpPr>
         <p:spPr>
           <a:xfrm>
-            <a:off x="6309360" y="6062472"/>
+            <a:off x="6309360" y="5824728"/>
             <a:ext cx="5303520" cy="219456"/>
           </a:xfrm>
           <a:prstGeom prst="rect">
@@ -6965,7 +6965,7 @@
                 <a:ea typeface="Calibri" pitchFamily="34" charset="-122"/>
                 <a:cs typeface="Calibri" pitchFamily="34" charset="-120"/>
               </a:rPr>
-              <a:t>6 мест на крошке, вне ограждения</a:t>
+              <a:t>40 п.м по северной границе, крутой склон</a:t>
             </a:r>
             <a:endParaRPr lang="en-US" sz="1050" dirty="0"/>
           </a:p>
@@ -8473,7 +8473,7 @@
                 <a:ea typeface="Cambria" pitchFamily="34" charset="-122"/>
                 <a:cs typeface="Cambria" pitchFamily="34" charset="-120"/>
               </a:rPr>
-              <a:t>Две таблички под золото</a:t>
+              <a:t>Таблички клуба и библиотеки</a:t>
             </a:r>
             <a:endParaRPr lang="en-US" sz="1600" dirty="0"/>
           </a:p>
@@ -8515,7 +8515,7 @@
                 <a:ea typeface="Calibri" pitchFamily="34" charset="-122"/>
                 <a:cs typeface="Calibri" pitchFamily="34" charset="-120"/>
               </a:rPr>
-              <a:t>«Любино-Малоросский Старожильский клуб» и «Библиотека» — в один ряд у угла фасада.</a:t>
+              <a:t>Существующие, в смету не входят. На южном фасаде у угла, справа от дорожки, в один ряд на отметке 2,35 м — в модели показаны для ориентации.</a:t>
             </a:r>
             <a:endParaRPr lang="en-US" sz="1100" dirty="0"/>
           </a:p>

</xml_diff>

<commit_message>
Narrow the drain works to pipe replacement and trench deepening
The septic's rings are in place, so the inspection chamber leaves the
schedule and the trench line becomes deepening an existing trench to
2.0 m rather than cutting a new one. The note now says the length of
20 m is the owner's figure and still needs confirming by survey.

38 items, 3 186 630 RUB direct plus 5 per cent, 3 345 962 RUB total,
154 038 RUB of headroom.

Co-Authored-By: Claude Opus 5 <noreply@anthropic.com>
Claude-Session: https://claude.ai/code/session_01BYykK3eroz4Z1NYhLotbmM
</commit_message>
<xml_diff>
--- a/polyanka-prezentaciya.pptx
+++ b/polyanka-prezentaciya.pptx
@@ -231,7 +231,7 @@
                   <c:v>18000</c:v>
                 </c:pt>
                 <c:pt idx="6">
-                  <c:v>140620</c:v>
+                  <c:v>114620</c:v>
                 </c:pt>
               </c:numCache>
             </c:numRef>
@@ -2581,7 +2581,7 @@
                 <a:ea typeface="Cambria" pitchFamily="34" charset="-122"/>
                 <a:cs typeface="Cambria" pitchFamily="34" charset="-120"/>
               </a:rPr>
-              <a:t>3 373 262 ₽</a:t>
+              <a:t>3 345 962 ₽</a:t>
             </a:r>
             <a:endParaRPr lang="en-US" sz="1700" dirty="0"/>
           </a:p>
@@ -3183,7 +3183,7 @@
                 <a:ea typeface="Cambria" pitchFamily="34" charset="-122"/>
                 <a:cs typeface="Cambria" pitchFamily="34" charset="-120"/>
               </a:rPr>
-              <a:t>3 373 262 ₽ при лимите 3,5 млн</a:t>
+              <a:t>3 345 962 ₽ при лимите 3,5 млн</a:t>
             </a:r>
             <a:endParaRPr lang="en-US" sz="3200" dirty="0"/>
           </a:p>
@@ -3222,7 +3222,7 @@
                 <a:ea typeface="Calibri" pitchFamily="34" charset="-122"/>
                 <a:cs typeface="Calibri" pitchFamily="34" charset="-120"/>
               </a:rPr>
-              <a:t>39 позиций в семи разделах. Расценки укрупнённые, до подачи подтверждаются коммерческими предложениями.</a:t>
+              <a:t>38 позиций в семи разделах. Расценки укрупнённые, до подачи подтверждаются коммерческими предложениями.</a:t>
             </a:r>
             <a:endParaRPr lang="en-US" sz="1250" dirty="0"/>
           </a:p>
@@ -3277,7 +3277,7 @@
                 <a:ea typeface="Cambria" pitchFamily="34" charset="-122"/>
                 <a:cs typeface="Cambria" pitchFamily="34" charset="-120"/>
               </a:rPr>
-              <a:t>3 212 630 ₽</a:t>
+              <a:t>3 186 630 ₽</a:t>
             </a:r>
             <a:endParaRPr lang="en-US" sz="2100" dirty="0"/>
           </a:p>
@@ -3355,7 +3355,7 @@
                 <a:ea typeface="Cambria" pitchFamily="34" charset="-122"/>
                 <a:cs typeface="Cambria" pitchFamily="34" charset="-120"/>
               </a:rPr>
-              <a:t>160 632 ₽</a:t>
+              <a:t>159 332 ₽</a:t>
             </a:r>
             <a:endParaRPr lang="en-US" sz="2100" dirty="0"/>
           </a:p>
@@ -3433,7 +3433,7 @@
                 <a:ea typeface="Cambria" pitchFamily="34" charset="-122"/>
                 <a:cs typeface="Cambria" pitchFamily="34" charset="-120"/>
               </a:rPr>
-              <a:t>126 738 ₽</a:t>
+              <a:t>154 038 ₽</a:t>
             </a:r>
             <a:endParaRPr lang="en-US" sz="2100" dirty="0"/>
           </a:p>
@@ -3472,7 +3472,7 @@
                 <a:ea typeface="Calibri" pitchFamily="34" charset="-122"/>
                 <a:cs typeface="Calibri" pitchFamily="34" charset="-120"/>
               </a:rPr>
-              <a:t>запас до лимита, 3,6 %</a:t>
+              <a:t>запас до лимита, 4,4 %</a:t>
             </a:r>
             <a:endParaRPr lang="en-US" sz="1100" dirty="0"/>
           </a:p>
@@ -4276,7 +4276,7 @@
                 <a:ea typeface="Cambria" pitchFamily="34" charset="-122"/>
                 <a:cs typeface="Cambria" pitchFamily="34" charset="-120"/>
               </a:rPr>
-              <a:t>3 373 262 ₽</a:t>
+              <a:t>3 345 962 ₽</a:t>
             </a:r>
             <a:endParaRPr lang="en-US" sz="2800" dirty="0"/>
           </a:p>
@@ -7069,7 +7069,7 @@
                 <a:ea typeface="Calibri" pitchFamily="34" charset="-122"/>
                 <a:cs typeface="Calibri" pitchFamily="34" charset="-120"/>
               </a:rPr>
-              <a:t>Замена наружной канализации</a:t>
+              <a:t>Замена трубы канализации</a:t>
             </a:r>
             <a:endParaRPr lang="en-US" sz="1250" dirty="0"/>
           </a:p>
@@ -7108,7 +7108,7 @@
                 <a:ea typeface="Calibri" pitchFamily="34" charset="-122"/>
                 <a:cs typeface="Calibri" pitchFamily="34" charset="-120"/>
               </a:rPr>
-              <a:t>20 п.м от выпуска здания до септика, h = 2,0 м</a:t>
+              <a:t>20 п.м от выпуска до септика, траншея до 2,0 м</a:t>
             </a:r>
             <a:endParaRPr lang="en-US" sz="1050" dirty="0"/>
           </a:p>

</xml_diff>

<commit_message>
Apply the plinth and rubber cuts, move the gazebo back to the gates
Two scope cuts bring the schedule back under the ceiling: the fence
loses its concrete strip plinth (posts are point-concreted, the panels
sit 150 mm clear of grade) and the playground loses its rubber, running
on 300 mm of sand throughout — equivalent under GOST R EN 1177, with
topping up and raking falling to the club.

The gazebo returns to its first position just inside the gates. The spot
is chosen by sightline: the ray to the stage passes west of the club and
the ray to the playground passes south of it, so a parent sitting there
keeps both the performance and the children in view.

38 items, 3 169 050 RUB direct plus 5 per cent, 3 327 503 RUB total,
172 497 RUB of headroom. Play equipment is untouched.

Co-Authored-By: Claude Opus 5 <noreply@anthropic.com>
Claude-Session: https://claude.ai/code/session_01BYykK3eroz4Z1NYhLotbmM
</commit_message>
<xml_diff>
--- a/polyanka-prezentaciya.pptx
+++ b/polyanka-prezentaciya.pptx
@@ -216,7 +216,7 @@
                   <c:v>218760</c:v>
                 </c:pt>
                 <c:pt idx="1">
-                  <c:v>963720</c:v>
+                  <c:v>806680</c:v>
                 </c:pt>
                 <c:pt idx="2">
                   <c:v>462000</c:v>
@@ -225,7 +225,7 @@
                   <c:v>713800</c:v>
                 </c:pt>
                 <c:pt idx="4">
-                  <c:v>966290</c:v>
+                  <c:v>835190</c:v>
                 </c:pt>
                 <c:pt idx="5">
                   <c:v>18000</c:v>
@@ -767,7 +767,7 @@
           <a:p>
             <a:r>
               <a:rPr lang="en-US" dirty="0"/>
-              <a:t>Проект благоустройства территории Старожильского клуба. Участок 55:11:100201:1471, 1712 м². Стоимость 3 179 463 руб. при лимите 3,5 млн.</a:t>
+              <a:t>Проект благоустройства территории Старожильского клуба. Участок 55:11:100201:1471, 1712 м². Стоимость 3 327 503 руб. при лимите 3,5 млн, запас 4,9 %.</a:t>
             </a:r>
             <a:endParaRPr lang="en-US" dirty="0"/>
           </a:p>
@@ -2581,7 +2581,7 @@
                 <a:ea typeface="Cambria" pitchFamily="34" charset="-122"/>
                 <a:cs typeface="Cambria" pitchFamily="34" charset="-120"/>
               </a:rPr>
-              <a:t>3 630 050 ₽</a:t>
+              <a:t>3 327 503 ₽</a:t>
             </a:r>
             <a:endParaRPr lang="en-US" sz="1700" dirty="0"/>
           </a:p>
@@ -3183,7 +3183,7 @@
                 <a:ea typeface="Cambria" pitchFamily="34" charset="-122"/>
                 <a:cs typeface="Cambria" pitchFamily="34" charset="-120"/>
               </a:rPr>
-              <a:t>3 630 050 ₽ — превышение лимита</a:t>
+              <a:t>3 327 503 ₽ при лимите 3,5 млн</a:t>
             </a:r>
             <a:endParaRPr lang="en-US" sz="3200" dirty="0"/>
           </a:p>
@@ -3222,7 +3222,7 @@
                 <a:ea typeface="Calibri" pitchFamily="34" charset="-122"/>
                 <a:cs typeface="Calibri" pitchFamily="34" charset="-120"/>
               </a:rPr>
-              <a:t>41 позиция в семи разделах. Расценки укрупнённые, до подачи подтверждаются коммерческими предложениями.</a:t>
+              <a:t>38 позиций в семи разделах. Расценки укрупнённые, до подачи подтверждаются коммерческими предложениями.</a:t>
             </a:r>
             <a:endParaRPr lang="en-US" sz="1250" dirty="0"/>
           </a:p>
@@ -3277,7 +3277,7 @@
                 <a:ea typeface="Cambria" pitchFamily="34" charset="-122"/>
                 <a:cs typeface="Cambria" pitchFamily="34" charset="-120"/>
               </a:rPr>
-              <a:t>3 457 190 ₽</a:t>
+              <a:t>3 169 050 ₽</a:t>
             </a:r>
             <a:endParaRPr lang="en-US" sz="2100" dirty="0"/>
           </a:p>
@@ -3355,7 +3355,7 @@
                 <a:ea typeface="Cambria" pitchFamily="34" charset="-122"/>
                 <a:cs typeface="Cambria" pitchFamily="34" charset="-120"/>
               </a:rPr>
-              <a:t>172 860 ₽</a:t>
+              <a:t>158 453 ₽</a:t>
             </a:r>
             <a:endParaRPr lang="en-US" sz="2100" dirty="0"/>
           </a:p>
@@ -3433,7 +3433,7 @@
                 <a:ea typeface="Cambria" pitchFamily="34" charset="-122"/>
                 <a:cs typeface="Cambria" pitchFamily="34" charset="-120"/>
               </a:rPr>
-              <a:t>−130 050 ₽</a:t>
+              <a:t>172 497 ₽</a:t>
             </a:r>
             <a:endParaRPr lang="en-US" sz="2100" dirty="0"/>
           </a:p>
@@ -3472,7 +3472,7 @@
                 <a:ea typeface="Calibri" pitchFamily="34" charset="-122"/>
                 <a:cs typeface="Calibri" pitchFamily="34" charset="-120"/>
               </a:rPr>
-              <a:t>превышение лимита, 3,7 %</a:t>
+              <a:t>запас до лимита, 4,9 %</a:t>
             </a:r>
             <a:endParaRPr lang="en-US" sz="1100" dirty="0"/>
           </a:p>
@@ -3486,8 +3486,8 @@
         </p:nvSpPr>
         <p:spPr>
           <a:xfrm>
-            <a:off x="7772400" y="5029200"/>
-            <a:ext cx="3794760" cy="1280160"/>
+            <a:off x="7772400" y="4846320"/>
+            <a:ext cx="3794760" cy="1508760"/>
           </a:xfrm>
           <a:prstGeom prst="rect">
             <a:avLst/>
@@ -3506,7 +3506,7 @@
         </p:nvSpPr>
         <p:spPr>
           <a:xfrm>
-            <a:off x="8001000" y="5193792"/>
+            <a:off x="8001000" y="4983480"/>
             <a:ext cx="3383280" cy="237744"/>
           </a:xfrm>
           <a:prstGeom prst="rect">
@@ -3545,8 +3545,8 @@
         </p:nvSpPr>
         <p:spPr>
           <a:xfrm>
-            <a:off x="8001000" y="5468112"/>
-            <a:ext cx="3383280" cy="777240"/>
+            <a:off x="8001000" y="5248656"/>
+            <a:ext cx="3383280" cy="1051560"/>
           </a:xfrm>
           <a:prstGeom prst="rect">
             <a:avLst/>
@@ -3560,12 +3560,12 @@
           <a:p>
             <a:pPr indent="0" marL="0">
               <a:lnSpc>
-                <a:spcPts val="1300"/>
+                <a:spcPts val="1250"/>
               </a:lnSpc>
               <a:buNone/>
             </a:pPr>
             <a:r>
-              <a:rPr lang="en-US" sz="1050" dirty="0">
+              <a:rPr lang="en-US" sz="980" dirty="0">
                 <a:solidFill>
                   <a:srgbClr val="15201A"/>
                 </a:solidFill>
@@ -3573,9 +3573,9 @@
                 <a:ea typeface="Calibri" pitchFamily="34" charset="-122"/>
                 <a:cs typeface="Calibri" pitchFamily="34" charset="-120"/>
               </a:rPr>
-              <a:t>Ограждение с трёх сторон по образцу заказчика поднимает смету выше лимита на 130 050 ₽ — объём требует сокращения до подачи. Варианты: отказ от бетонного цоколя, ограждение в две очереди или замена резинового покрытия песком.</a:t>
-            </a:r>
-            <a:endParaRPr lang="en-US" sz="1050" dirty="0"/>
+              <a:t>Ради нового ограждения отказались от бетонного цоколя под забором и от резинового покрытия: площадка целиком на песке 30 см — по ГОСТ Р ЕН 1177 это равноценно. Состав объектов и игровое оборудование сохранены.</a:t>
+            </a:r>
+            <a:endParaRPr lang="en-US" sz="980" dirty="0"/>
           </a:p>
         </p:txBody>
       </p:sp>
@@ -4276,7 +4276,7 @@
                 <a:ea typeface="Cambria" pitchFamily="34" charset="-122"/>
                 <a:cs typeface="Cambria" pitchFamily="34" charset="-120"/>
               </a:rPr>
-              <a:t>3 630 050 ₽</a:t>
+              <a:t>3 327 503 ₽</a:t>
             </a:r>
             <a:endParaRPr lang="en-US" sz="2800" dirty="0"/>
           </a:p>
@@ -6423,7 +6423,7 @@
                 <a:ea typeface="Calibri" pitchFamily="34" charset="-122"/>
                 <a:cs typeface="Calibri" pitchFamily="34" charset="-120"/>
               </a:rPr>
-              <a:t>в начале восточной полосы, кровля «Каскад»</a:t>
+              <a:t>справа от ворот, створы на сцену и площадку</a:t>
             </a:r>
             <a:endParaRPr lang="en-US" sz="1050" dirty="0"/>
           </a:p>
@@ -6971,7 +6971,7 @@
                 <a:ea typeface="Calibri" pitchFamily="34" charset="-122"/>
                 <a:cs typeface="Calibri" pitchFamily="34" charset="-120"/>
               </a:rPr>
-              <a:t>114 п.м с трёх сторон, на бетонном цоколе</a:t>
+              <a:t>114 п.м с трёх сторон, столбы с бетонированием</a:t>
             </a:r>
             <a:endParaRPr lang="en-US" sz="1050" dirty="0"/>
           </a:p>

</xml_diff>